<commit_message>
slides(course): add ch02-slides.pptx for claude-tool-use-from-zero ch02 [KOEA-2259]
7 slides: title + 5 content (MCP architecture, primitives, anti-patterns,
Claude Code config, hands-on workflow) + Try-it-next CTA.
Adds scripts/generate_course_slides.py for future course chapter decks.

Co-Authored-By: Claude Sonnet 4.6 <noreply@anthropic.com>
</commit_message>
<xml_diff>
--- a/vault/courses/claude-tool-use-from-zero/ch02-slides.pptx
+++ b/vault/courses/claude-tool-use-from-zero/ch02-slides.pptx
@@ -3144,6 +3144,40 @@
         </p:nvSpPr>
         <p:spPr>
           <a:xfrm>
+            <a:off x="914400" y="4297680"/>
+            <a:ext cx="10332720" cy="457200"/>
+          </a:xfrm>
+          <a:prstGeom prst="rect">
+            <a:avLst/>
+          </a:prstGeom>
+          <a:noFill/>
+        </p:spPr>
+        <p:txBody>
+          <a:bodyPr wrap="square">
+            <a:spAutoFit/>
+          </a:bodyPr>
+          <a:lstStyle/>
+          <a:p>
+            <a:pPr algn="ctr"/>
+            <a:r>
+              <a:rPr sz="1600" b="0">
+                <a:solidFill>
+                  <a:srgbClr val="A1A1AA"/>
+                </a:solidFill>
+              </a:rPr>
+              <a:t>Chapter 2 · Claude Tool Use From Zero</a:t>
+            </a:r>
+          </a:p>
+        </p:txBody>
+      </p:sp>
+      <p:sp>
+        <p:nvSpPr>
+          <p:cNvPr id="4" name="TextBox 3"/>
+          <p:cNvSpPr txBox="1"/>
+          <p:nvPr/>
+        </p:nvSpPr>
+        <p:spPr>
+          <a:xfrm>
             <a:off x="731520" y="6263640"/>
             <a:ext cx="10698480" cy="365760"/>
           </a:xfrm>
@@ -3220,12 +3254,12 @@
           <a:p>
             <a:pPr algn="l"/>
             <a:r>
-              <a:rPr sz="2800" b="1">
+              <a:rPr sz="2600" b="1">
                 <a:solidFill>
                   <a:srgbClr val="FFFFFF"/>
                 </a:solidFill>
               </a:rPr>
-              <a:t>Prerequisites check</a:t>
+              <a:t>MCP architecture: host, client, server, transport.</a:t>
             </a:r>
           </a:p>
         </p:txBody>
@@ -3302,7 +3336,7 @@
                   <a:srgbClr val="FFFFFF"/>
                 </a:solidFill>
               </a:rPr>
-              <a:t>  You should already be able to explain a tool_use block, a tool input schema, and a tool_result. If not, repeat the Chapter 1 hands-on before</a:t>
+              <a:t>  The MCP architecture is easiest to understand as a responsibility split:</a:t>
             </a:r>
           </a:p>
         </p:txBody>
@@ -3310,6 +3344,108 @@
       <p:sp>
         <p:nvSpPr>
           <p:cNvPr id="5" name="TextBox 4"/>
+          <p:cNvSpPr txBox="1"/>
+          <p:nvPr/>
+        </p:nvSpPr>
+        <p:spPr>
+          <a:xfrm>
+            <a:off x="731520" y="2651760"/>
+            <a:ext cx="10698480" cy="960120"/>
+          </a:xfrm>
+          <a:prstGeom prst="rect">
+            <a:avLst/>
+          </a:prstGeom>
+          <a:noFill/>
+        </p:spPr>
+        <p:txBody>
+          <a:bodyPr wrap="square">
+            <a:spAutoFit/>
+          </a:bodyPr>
+          <a:lstStyle/>
+          <a:p>
+            <a:pPr algn="l"/>
+            <a:r>
+              <a:rPr sz="1700" b="0">
+                <a:solidFill>
+                  <a:srgbClr val="FFFFFF"/>
+                </a:solidFill>
+              </a:rPr>
+              <a:t>  Claude Code's MCP documentation shows three broad connection options: remote HTTP servers, remote SSE servers, and local</a:t>
+            </a:r>
+          </a:p>
+        </p:txBody>
+      </p:sp>
+      <p:sp>
+        <p:nvSpPr>
+          <p:cNvPr id="6" name="TextBox 5"/>
+          <p:cNvSpPr txBox="1"/>
+          <p:nvPr/>
+        </p:nvSpPr>
+        <p:spPr>
+          <a:xfrm>
+            <a:off x="731520" y="3703320"/>
+            <a:ext cx="10698480" cy="960120"/>
+          </a:xfrm>
+          <a:prstGeom prst="rect">
+            <a:avLst/>
+          </a:prstGeom>
+          <a:noFill/>
+        </p:spPr>
+        <p:txBody>
+          <a:bodyPr wrap="square">
+            <a:spAutoFit/>
+          </a:bodyPr>
+          <a:lstStyle/>
+          <a:p>
+            <a:pPr algn="l"/>
+            <a:r>
+              <a:rPr sz="1700" b="0">
+                <a:solidFill>
+                  <a:srgbClr val="FFFFFF"/>
+                </a:solidFill>
+              </a:rPr>
+              <a:t>  For a beginner, this gives you a clear decision tree:</a:t>
+            </a:r>
+          </a:p>
+        </p:txBody>
+      </p:sp>
+      <p:sp>
+        <p:nvSpPr>
+          <p:cNvPr id="7" name="TextBox 6"/>
+          <p:cNvSpPr txBox="1"/>
+          <p:nvPr/>
+        </p:nvSpPr>
+        <p:spPr>
+          <a:xfrm>
+            <a:off x="731520" y="4754880"/>
+            <a:ext cx="10698480" cy="960120"/>
+          </a:xfrm>
+          <a:prstGeom prst="rect">
+            <a:avLst/>
+          </a:prstGeom>
+          <a:noFill/>
+        </p:spPr>
+        <p:txBody>
+          <a:bodyPr wrap="square">
+            <a:spAutoFit/>
+          </a:bodyPr>
+          <a:lstStyle/>
+          <a:p>
+            <a:pPr algn="l"/>
+            <a:r>
+              <a:rPr sz="1700" b="0">
+                <a:solidFill>
+                  <a:srgbClr val="FFFFFF"/>
+                </a:solidFill>
+              </a:rPr>
+              <a:t>  Use local stdio when the server is a local script or needs direct local machine access.</a:t>
+            </a:r>
+          </a:p>
+        </p:txBody>
+      </p:sp>
+      <p:sp>
+        <p:nvSpPr>
+          <p:cNvPr id="8" name="TextBox 7"/>
           <p:cNvSpPr txBox="1"/>
           <p:nvPr/>
         </p:nvSpPr>
@@ -3391,12 +3527,12 @@
           <a:p>
             <a:pPr algn="l"/>
             <a:r>
-              <a:rPr sz="2800" b="1">
+              <a:rPr sz="2600" b="1">
                 <a:solidFill>
                   <a:srgbClr val="FFFFFF"/>
                 </a:solidFill>
               </a:rPr>
-              <a:t>What MCP adds</a:t>
+              <a:t>Tools vs resources vs prompts, using accounts-receivable examples.</a:t>
             </a:r>
           </a:p>
         </p:txBody>
@@ -3473,7 +3609,7 @@
                   <a:srgbClr val="FFFFFF"/>
                 </a:solidFill>
               </a:rPr>
-              <a:t>  MCP gives you three practical upgrades:</a:t>
+              <a:t>  MCP has several protocol concepts, but this course starts with the three primitives you will use constantly: tools, reso</a:t>
             </a:r>
           </a:p>
         </p:txBody>
@@ -3507,7 +3643,7 @@
                   <a:srgbClr val="FFFFFF"/>
                 </a:solidFill>
               </a:rPr>
-              <a:t>  Discovery: a host can ask a server what it offers instead of hard-coding every function in the host.</a:t>
+              <a:t>  Tools are callable actions. The MCP tools specification describes tools as functions exposed by a server that can be inv</a:t>
             </a:r>
           </a:p>
         </p:txBody>
@@ -3541,7 +3677,7 @@
                   <a:srgbClr val="FFFFFF"/>
                 </a:solidFill>
               </a:rPr>
-              <a:t>  Reuse: one MCP server can serve many hosts.</a:t>
+              <a:t>  Resources are readable context. The MCP resources specification describes resources as data exposed by servers that clie</a:t>
             </a:r>
           </a:p>
         </p:txBody>
@@ -3575,7 +3711,7 @@
                   <a:srgbClr val="FFFFFF"/>
                 </a:solidFill>
               </a:rPr>
-              <a:t>  Separation: the connector owner can maintain auth, data access, and domain logic outside the LLM application.</a:t>
+              <a:t>  Prompts are reusable prompt templates. The MCP prompts specification describes prompts as server-provided templates that</a:t>
             </a:r>
           </a:p>
         </p:txBody>
@@ -3664,12 +3800,12 @@
           <a:p>
             <a:pPr algn="l"/>
             <a:r>
-              <a:rPr sz="2800" b="1">
+              <a:rPr sz="2600" b="1">
                 <a:solidFill>
                   <a:srgbClr val="FFFFFF"/>
                 </a:solidFill>
               </a:rPr>
-              <a:t>Host, client, server</a:t>
+              <a:t>Anti-patterns: raw executors, hidden writes, everything-as-tool.</a:t>
             </a:r>
           </a:p>
         </p:txBody>
@@ -3746,7 +3882,7 @@
                   <a:srgbClr val="FFFFFF"/>
                 </a:solidFill>
               </a:rPr>
-              <a:t>  MCP uses three terms that are easy to blur:</a:t>
+              <a:t>  The first anti-pattern is the raw executor tool: run_shell, query_sql, http_request, or eval_code. These are attractive </a:t>
             </a:r>
           </a:p>
         </p:txBody>
@@ -3780,7 +3916,7 @@
                   <a:srgbClr val="FFFFFF"/>
                 </a:solidFill>
               </a:rPr>
-              <a:t>  Host: the user-facing AI application, such as Claude Code or another agent UI.</a:t>
+              <a:t>  The second anti-pattern is hiding writes behind harmless names. A tool named sync_customer might update a CRM, email an </a:t>
             </a:r>
           </a:p>
         </p:txBody>
@@ -3814,7 +3950,7 @@
                   <a:srgbClr val="FFFFFF"/>
                 </a:solidFill>
               </a:rPr>
-              <a:t>  Client: the protocol component inside the host that speaks MCP.</a:t>
+              <a:t>  The third anti-pattern is modeling everything as a tool. Policies, schemas, runbooks, and reference docs should usually </a:t>
             </a:r>
           </a:p>
         </p:txBody>
@@ -3848,7 +3984,7 @@
                   <a:srgbClr val="FFFFFF"/>
                 </a:solidFill>
               </a:rPr>
-              <a:t>  Server: the external process or service that exposes capabilities.</a:t>
+              <a:t>  The fourth anti-pattern is modeling a workflow prompt as application code only. If the connector's domain expertise incl</a:t>
             </a:r>
           </a:p>
         </p:txBody>
@@ -3937,12 +4073,12 @@
           <a:p>
             <a:pPr algn="l"/>
             <a:r>
-              <a:rPr sz="2800" b="1">
+              <a:rPr sz="2600" b="1">
                 <a:solidFill>
                   <a:srgbClr val="FFFFFF"/>
                 </a:solidFill>
               </a:rPr>
-              <a:t>Tools, resources, and prompts</a:t>
+              <a:t>Claude Code configuration: stdio vs HTTP, scope, secrets.</a:t>
             </a:r>
           </a:p>
         </p:txBody>
@@ -4019,7 +4155,7 @@
                   <a:srgbClr val="FFFFFF"/>
                 </a:solidFill>
               </a:rPr>
-              <a:t>  Tools are callable actions. Use tools for operations like search_invoices, create_support_ticket, or lookup_stock_price.</a:t>
+              <a:t>  Now connect the architecture to the command line.</a:t>
             </a:r>
           </a:p>
         </p:txBody>
@@ -4053,7 +4189,7 @@
                   <a:srgbClr val="FFFFFF"/>
                 </a:solidFill>
               </a:rPr>
-              <a:t>  Resources are context objects the model can read. Use resources for project files, policy documents, account summaries, or configuration rec</a:t>
+              <a:t>  Claude Code can add a local stdio server with a command shaped like this:</a:t>
             </a:r>
           </a:p>
         </p:txBody>
@@ -4087,7 +4223,7 @@
                   <a:srgbClr val="FFFFFF"/>
                 </a:solidFill>
               </a:rPr>
-              <a:t>  Prompts are reusable prompt templates exposed by the server. Use prompts when a connector knows the right instruction pattern for a workflow</a:t>
+              <a:t>  claude mcp add --transport stdio --env FINANCE_API_KEY=demo finance-demo -- node ./server.js</a:t>
             </a:r>
           </a:p>
         </p:txBody>
@@ -4121,7 +4257,7 @@
                   <a:srgbClr val="FFFFFF"/>
                 </a:solidFill>
               </a:rPr>
-              <a:t>  model="claude-sonnet-4-6"</a:t>
+              <a:t>  Read it from left to right:</a:t>
             </a:r>
           </a:p>
         </p:txBody>
@@ -4210,12 +4346,12 @@
           <a:p>
             <a:pPr algn="l"/>
             <a:r>
-              <a:rPr sz="2800" b="1">
+              <a:rPr sz="2600" b="1">
                 <a:solidFill>
                   <a:srgbClr val="FFFFFF"/>
                 </a:solidFill>
               </a:rPr>
-              <a:t>Why this matters for connector design</a:t>
+              <a:t>Hands-on workflow: connect, inspect, classify, critique.</a:t>
             </a:r>
           </a:p>
         </p:txBody>
@@ -4292,7 +4428,7 @@
                   <a:srgbClr val="FFFFFF"/>
                 </a:solidFill>
               </a:rPr>
-              <a:t>  Bad MCP servers expose raw platform primitives: http_request, sql_query, run_command. Good MCP servers expose business capabilities: get_cus</a:t>
+              <a:t>  Your goal is to connect Claude Code to one existing MCP server in a sandbox environment and inspect what it advertises. </a:t>
             </a:r>
           </a:p>
         </p:txBody>
@@ -4326,7 +4462,7 @@
                   <a:srgbClr val="FFFFFF"/>
                 </a:solidFill>
               </a:rPr>
-              <a:t>  The connector designer's job is not to mirror every endpoint. It is to decide which operations are safe, useful, observable, and understanda</a:t>
+              <a:t>  Use any safe server you already trust, or create a temporary demo server from official SDK examples. The TypeScript SDK </a:t>
             </a:r>
           </a:p>
         </p:txBody>
@@ -4334,6 +4470,74 @@
       <p:sp>
         <p:nvSpPr>
           <p:cNvPr id="6" name="TextBox 5"/>
+          <p:cNvSpPr txBox="1"/>
+          <p:nvPr/>
+        </p:nvSpPr>
+        <p:spPr>
+          <a:xfrm>
+            <a:off x="731520" y="3703320"/>
+            <a:ext cx="10698480" cy="960120"/>
+          </a:xfrm>
+          <a:prstGeom prst="rect">
+            <a:avLst/>
+          </a:prstGeom>
+          <a:noFill/>
+        </p:spPr>
+        <p:txBody>
+          <a:bodyPr wrap="square">
+            <a:spAutoFit/>
+          </a:bodyPr>
+          <a:lstStyle/>
+          <a:p>
+            <a:pPr algn="l"/>
+            <a:r>
+              <a:rPr sz="1700" b="0">
+                <a:solidFill>
+                  <a:srgbClr val="FFFFFF"/>
+                </a:solidFill>
+              </a:rPr>
+              <a:t>  Step 1: choose the server</a:t>
+            </a:r>
+          </a:p>
+        </p:txBody>
+      </p:sp>
+      <p:sp>
+        <p:nvSpPr>
+          <p:cNvPr id="7" name="TextBox 6"/>
+          <p:cNvSpPr txBox="1"/>
+          <p:nvPr/>
+        </p:nvSpPr>
+        <p:spPr>
+          <a:xfrm>
+            <a:off x="731520" y="4754880"/>
+            <a:ext cx="10698480" cy="960120"/>
+          </a:xfrm>
+          <a:prstGeom prst="rect">
+            <a:avLst/>
+          </a:prstGeom>
+          <a:noFill/>
+        </p:spPr>
+        <p:txBody>
+          <a:bodyPr wrap="square">
+            <a:spAutoFit/>
+          </a:bodyPr>
+          <a:lstStyle/>
+          <a:p>
+            <a:pPr algn="l"/>
+            <a:r>
+              <a:rPr sz="1700" b="0">
+                <a:solidFill>
+                  <a:srgbClr val="FFFFFF"/>
+                </a:solidFill>
+              </a:rPr>
+              <a:t>  Pick one of these:</a:t>
+            </a:r>
+          </a:p>
+        </p:txBody>
+      </p:sp>
+      <p:sp>
+        <p:nvSpPr>
+          <p:cNvPr id="8" name="TextBox 7"/>
           <p:cNvSpPr txBox="1"/>
           <p:nvPr/>
         </p:nvSpPr>
@@ -4415,12 +4619,12 @@
           <a:p>
             <a:pPr algn="ctr"/>
             <a:r>
-              <a:rPr sz="3400" b="1">
+              <a:rPr sz="2800" b="1">
                 <a:solidFill>
                   <a:srgbClr val="FFFFFF"/>
                 </a:solidFill>
               </a:rPr>
-              <a:t>Try it next</a:t>
+              <a:t>Try it next: Chapter 3 turns this architecture into code</a:t>
             </a:r>
           </a:p>
         </p:txBody>
@@ -4434,7 +4638,7 @@
         <p:spPr>
           <a:xfrm>
             <a:off x="914400" y="3200400"/>
-            <a:ext cx="10332720" cy="1097280"/>
+            <a:ext cx="10332720" cy="822960"/>
           </a:xfrm>
           <a:prstGeom prst="rect">
             <a:avLst/>
@@ -4449,12 +4653,12 @@
           <a:p>
             <a:pPr algn="ctr"/>
             <a:r>
-              <a:rPr sz="2000" b="0">
+              <a:rPr sz="3600" b="1">
                 <a:solidFill>
                   <a:srgbClr val="A1A1AA"/>
                 </a:solidFill>
               </a:rPr>
-              <a:t>Deploy a gateway with RBAC, rate limits, and JSONL auditing</a:t>
+              <a:t>academy.kspl.tech</a:t>
             </a:r>
           </a:p>
         </p:txBody>
@@ -4467,8 +4671,8 @@
         </p:nvSpPr>
         <p:spPr>
           <a:xfrm>
-            <a:off x="731520" y="6263640"/>
-            <a:ext cx="10698480" cy="365760"/>
+            <a:off x="914400" y="6263640"/>
+            <a:ext cx="10332720" cy="365760"/>
           </a:xfrm>
           <a:prstGeom prst="rect">
             <a:avLst/>
@@ -4481,14 +4685,14 @@
           </a:bodyPr>
           <a:lstStyle/>
           <a:p>
-            <a:pPr algn="l"/>
-            <a:r>
-              <a:rPr sz="1000" b="0">
+            <a:pPr algn="ctr"/>
+            <a:r>
+              <a:rPr sz="1200" b="0">
                 <a:solidFill>
                   <a:srgbClr val="A1A1AA"/>
                 </a:solidFill>
               </a:rPr>
-              <a:t>academy.kspl.tech | Koenig AI Academy</a:t>
+              <a:t>Koenig AI Academy</a:t>
             </a:r>
           </a:p>
         </p:txBody>

</xml_diff>

<commit_message>
fix(slides): KOEA-8285 — address all 4 G0 blockers in ch02-slides.pptx
- BLOCKER 1: slides 2-6 now match spec titles (MCP architecture, Tools vs resources vs prompts, Anti-patterns, Claude Code config, Hands-on workflow)
- BLOCKER 2: removed model="claude-sonnet-4-6" artifact from slide 5; replaced with secrets-management guidance
- BLOCKER 3: slide 2 (MCP architecture) now has 4 proper bullets instead of one long paragraph
- BLOCKER 4: slide 7 (Try it next) now has 3 bullets: 2 recap + 1 CTA

Co-Authored-By: Claude Sonnet 4.6 <noreply@anthropic.com>
</commit_message>
<xml_diff>
--- a/vault/courses/claude-tool-use-from-zero/ch02-slides.pptx
+++ b/vault/courses/claude-tool-use-from-zero/ch02-slides.pptx
@@ -3225,7 +3225,7 @@
                   <a:srgbClr val="FFFFFF"/>
                 </a:solidFill>
               </a:rPr>
-              <a:t>Prerequisites check</a:t>
+              <a:t>MCP architecture: host, client, server, transport</a:t>
             </a:r>
           </a:p>
         </p:txBody>
@@ -3302,7 +3302,7 @@
                   <a:srgbClr val="FFFFFF"/>
                 </a:solidFill>
               </a:rPr>
-              <a:t>  You should already be able to explain a tool_use block, a tool input schema, and a tool_result. If not, repeat the Chapter 1 hands-on before</a:t>
+              <a:t>MCP defines four protocol roles. Map them before connecting any server.</a:t>
             </a:r>
           </a:p>
         </p:txBody>
@@ -3337,6 +3337,105 @@
                 </a:solidFill>
               </a:rPr>
               <a:t>academy.kspl.tech | Koenig AI Academy</a:t>
+            </a:r>
+          </a:p>
+        </p:txBody>
+      </p:sp>
+      <p:sp>
+        <p:nvSpPr>
+          <p:cNvPr id="6" name="TextBox 5"/>
+          <p:cNvSpPr txBox="1"/>
+          <p:nvPr/>
+        </p:nvSpPr>
+        <p:spPr>
+          <a:xfrm>
+            <a:off x="731520" y="2651760"/>
+            <a:ext cx="10698480" cy="960120"/>
+          </a:xfrm>
+          <a:prstGeom prst="rect">
+            <a:avLst/>
+          </a:prstGeom>
+          <a:noFill/>
+        </p:spPr>
+        <p:txBody>
+          <a:bodyPr wrap="square">
+            <a:spAutoFit/>
+          </a:bodyPr>
+          <a:lstStyle/>
+          <a:p>
+            <a:r>
+              <a:rPr sz="1700" b="0">
+                <a:solidFill>
+                  <a:srgbClr val="FFFFFF"/>
+                </a:solidFill>
+              </a:rPr>
+              <a:t>Host: the AI application that initiates model calls, e.g., Claude Code or your agent.</a:t>
+            </a:r>
+          </a:p>
+        </p:txBody>
+      </p:sp>
+      <p:sp>
+        <p:nvSpPr>
+          <p:cNvPr id="7" name="TextBox 6"/>
+          <p:cNvSpPr txBox="1"/>
+          <p:nvPr/>
+        </p:nvSpPr>
+        <p:spPr>
+          <a:xfrm>
+            <a:off x="731520" y="3703320"/>
+            <a:ext cx="10698480" cy="960120"/>
+          </a:xfrm>
+          <a:prstGeom prst="rect">
+            <a:avLst/>
+          </a:prstGeom>
+          <a:noFill/>
+        </p:spPr>
+        <p:txBody>
+          <a:bodyPr wrap="square">
+            <a:spAutoFit/>
+          </a:bodyPr>
+          <a:lstStyle/>
+          <a:p>
+            <a:r>
+              <a:rPr sz="1700" b="0">
+                <a:solidFill>
+                  <a:srgbClr val="FFFFFF"/>
+                </a:solidFill>
+              </a:rPr>
+              <a:t>Client: the in-process MCP component that speaks the protocol on the host's behalf.</a:t>
+            </a:r>
+          </a:p>
+        </p:txBody>
+      </p:sp>
+      <p:sp>
+        <p:nvSpPr>
+          <p:cNvPr id="8" name="TextBox 7"/>
+          <p:cNvSpPr txBox="1"/>
+          <p:nvPr/>
+        </p:nvSpPr>
+        <p:spPr>
+          <a:xfrm>
+            <a:off x="731520" y="4754880"/>
+            <a:ext cx="10698480" cy="960120"/>
+          </a:xfrm>
+          <a:prstGeom prst="rect">
+            <a:avLst/>
+          </a:prstGeom>
+          <a:noFill/>
+        </p:spPr>
+        <p:txBody>
+          <a:bodyPr wrap="square">
+            <a:spAutoFit/>
+          </a:bodyPr>
+          <a:lstStyle/>
+          <a:p>
+            <a:r>
+              <a:rPr sz="1700" b="0">
+                <a:solidFill>
+                  <a:srgbClr val="FFFFFF"/>
+                </a:solidFill>
+              </a:rPr>
+              <a:t>Server + transport: external process over stdio (local spawn) or HTTP/SSE (remote).</a:t>
             </a:r>
           </a:p>
         </p:txBody>
@@ -3396,7 +3495,7 @@
                   <a:srgbClr val="FFFFFF"/>
                 </a:solidFill>
               </a:rPr>
-              <a:t>What MCP adds</a:t>
+              <a:t>Tools vs resources vs prompts, using accounts-receivable examples</a:t>
             </a:r>
           </a:p>
         </p:txBody>
@@ -3473,7 +3572,7 @@
                   <a:srgbClr val="FFFFFF"/>
                 </a:solidFill>
               </a:rPr>
-              <a:t>  MCP gives you three practical upgrades:</a:t>
+              <a:t>Three primitives define what a server can offer. Pick the right type for each capability.</a:t>
             </a:r>
           </a:p>
         </p:txBody>
@@ -3507,7 +3606,7 @@
                   <a:srgbClr val="FFFFFF"/>
                 </a:solidFill>
               </a:rPr>
-              <a:t>  Discovery: a host can ask a server what it offers instead of hard-coding every function in the host.</a:t>
+              <a:t>Tools: callable actions with side-effects — post_payment, flag_overdue_invoice.</a:t>
             </a:r>
           </a:p>
         </p:txBody>
@@ -3541,7 +3640,7 @@
                   <a:srgbClr val="FFFFFF"/>
                 </a:solidFill>
               </a:rPr>
-              <a:t>  Reuse: one MCP server can serve many hosts.</a:t>
+              <a:t>Resources: context objects the model reads — ar_policy.pdf, customer_balance_sheet.</a:t>
             </a:r>
           </a:p>
         </p:txBody>
@@ -3575,7 +3674,7 @@
                   <a:srgbClr val="FFFFFF"/>
                 </a:solidFill>
               </a:rPr>
-              <a:t>  Separation: the connector owner can maintain auth, data access, and domain logic outside the LLM application.</a:t>
+              <a:t>Prompts: reusable templates — payment_reminder_draft, dispute_summary_template.</a:t>
             </a:r>
           </a:p>
         </p:txBody>
@@ -3669,7 +3768,7 @@
                   <a:srgbClr val="FFFFFF"/>
                 </a:solidFill>
               </a:rPr>
-              <a:t>Host, client, server</a:t>
+              <a:t>Anti-patterns: raw executors, hidden writes, everything-as-tool</a:t>
             </a:r>
           </a:p>
         </p:txBody>
@@ -3746,7 +3845,7 @@
                   <a:srgbClr val="FFFFFF"/>
                 </a:solidFill>
               </a:rPr>
-              <a:t>  MCP uses three terms that are easy to blur:</a:t>
+              <a:t>Three design failures make MCP servers unsafe, unpredictable, or hard to audit.</a:t>
             </a:r>
           </a:p>
         </p:txBody>
@@ -3780,7 +3879,7 @@
                   <a:srgbClr val="FFFFFF"/>
                 </a:solidFill>
               </a:rPr>
-              <a:t>  Host: the user-facing AI application, such as Claude Code or another agent UI.</a:t>
+              <a:t>Raw executors: exposing http_request, sql_query, or run_command hands a weapon to the model.</a:t>
             </a:r>
           </a:p>
         </p:txBody>
@@ -3814,7 +3913,7 @@
                   <a:srgbClr val="FFFFFF"/>
                 </a:solidFill>
               </a:rPr>
-              <a:t>  Client: the protocol component inside the host that speaks MCP.</a:t>
+              <a:t>Hidden writes: tools that silently mutate state without declaring the side-effect in their schema.</a:t>
             </a:r>
           </a:p>
         </p:txBody>
@@ -3848,7 +3947,7 @@
                   <a:srgbClr val="FFFFFF"/>
                 </a:solidFill>
               </a:rPr>
-              <a:t>  Server: the external process or service that exposes capabilities.</a:t>
+              <a:t>Everything-as-tool: forcing resources and prompts into tool shape loses their semantic contract.</a:t>
             </a:r>
           </a:p>
         </p:txBody>
@@ -3942,7 +4041,7 @@
                   <a:srgbClr val="FFFFFF"/>
                 </a:solidFill>
               </a:rPr>
-              <a:t>Tools, resources, and prompts</a:t>
+              <a:t>Claude Code configuration: stdio vs HTTP, scope, secrets</a:t>
             </a:r>
           </a:p>
         </p:txBody>
@@ -4019,7 +4118,7 @@
                   <a:srgbClr val="FFFFFF"/>
                 </a:solidFill>
               </a:rPr>
-              <a:t>  Tools are callable actions. Use tools for operations like search_invoices, create_support_ticket, or lookup_stock_price.</a:t>
+              <a:t>Claude Code reads MCP config from two scopes: global (~/.claude/) and project (.mcp.json).</a:t>
             </a:r>
           </a:p>
         </p:txBody>
@@ -4053,7 +4152,7 @@
                   <a:srgbClr val="FFFFFF"/>
                 </a:solidFill>
               </a:rPr>
-              <a:t>  Resources are context objects the model can read. Use resources for project files, policy documents, account summaries, or configuration rec</a:t>
+              <a:t>stdio transport: Claude Code spawns the server as a child process — use for local servers.</a:t>
             </a:r>
           </a:p>
         </p:txBody>
@@ -4087,7 +4186,7 @@
                   <a:srgbClr val="FFFFFF"/>
                 </a:solidFill>
               </a:rPr>
-              <a:t>  Prompts are reusable prompt templates exposed by the server. Use prompts when a connector knows the right instruction pattern for a workflow</a:t>
+              <a:t>HTTP/SSE transport: server runs independently at a URL — use for remote or shared servers.</a:t>
             </a:r>
           </a:p>
         </p:txBody>
@@ -4121,7 +4220,7 @@
                   <a:srgbClr val="FFFFFF"/>
                 </a:solidFill>
               </a:rPr>
-              <a:t>  model="claude-sonnet-4-6"</a:t>
+              <a:t>Secrets: pass credentials as env vars in the config block; never hardcode in the server URL.</a:t>
             </a:r>
           </a:p>
         </p:txBody>
@@ -4215,7 +4314,7 @@
                   <a:srgbClr val="FFFFFF"/>
                 </a:solidFill>
               </a:rPr>
-              <a:t>Why this matters for connector design</a:t>
+              <a:t>Hands-on workflow: connect, inspect, classify, critique</a:t>
             </a:r>
           </a:p>
         </p:txBody>
@@ -4292,7 +4391,7 @@
                   <a:srgbClr val="FFFFFF"/>
                 </a:solidFill>
               </a:rPr>
-              <a:t>  Bad MCP servers expose raw platform primitives: http_request, sql_query, run_command. Good MCP servers expose business capabilities: get_cus</a:t>
+              <a:t>Four steps to evaluate any MCP server before wiring it into a production agent.</a:t>
             </a:r>
           </a:p>
         </p:txBody>
@@ -4326,7 +4425,7 @@
                   <a:srgbClr val="FFFFFF"/>
                 </a:solidFill>
               </a:rPr>
-              <a:t>  The connector designer's job is not to mirror every endpoint. It is to decide which operations are safe, useful, observable, and understanda</a:t>
+              <a:t>Connect: add the server entry to .mcp.json, restart Claude Code, confirm green status.</a:t>
             </a:r>
           </a:p>
         </p:txBody>
@@ -4361,6 +4460,72 @@
                 </a:solidFill>
               </a:rPr>
               <a:t>academy.kspl.tech | Koenig AI Academy</a:t>
+            </a:r>
+          </a:p>
+        </p:txBody>
+      </p:sp>
+      <p:sp>
+        <p:nvSpPr>
+          <p:cNvPr id="7" name="TextBox 6"/>
+          <p:cNvSpPr txBox="1"/>
+          <p:nvPr/>
+        </p:nvSpPr>
+        <p:spPr>
+          <a:xfrm>
+            <a:off x="731520" y="3703320"/>
+            <a:ext cx="10698480" cy="960120"/>
+          </a:xfrm>
+          <a:prstGeom prst="rect">
+            <a:avLst/>
+          </a:prstGeom>
+          <a:noFill/>
+        </p:spPr>
+        <p:txBody>
+          <a:bodyPr wrap="square">
+            <a:spAutoFit/>
+          </a:bodyPr>
+          <a:lstStyle/>
+          <a:p>
+            <a:r>
+              <a:rPr sz="1700" b="0">
+                <a:solidFill>
+                  <a:srgbClr val="FFFFFF"/>
+                </a:solidFill>
+              </a:rPr>
+              <a:t>Inspect: run list tools, list resources, list prompts — record every capability name.</a:t>
+            </a:r>
+          </a:p>
+        </p:txBody>
+      </p:sp>
+      <p:sp>
+        <p:nvSpPr>
+          <p:cNvPr id="8" name="TextBox 7"/>
+          <p:cNvSpPr txBox="1"/>
+          <p:nvPr/>
+        </p:nvSpPr>
+        <p:spPr>
+          <a:xfrm>
+            <a:off x="731520" y="4754880"/>
+            <a:ext cx="10698480" cy="960120"/>
+          </a:xfrm>
+          <a:prstGeom prst="rect">
+            <a:avLst/>
+          </a:prstGeom>
+          <a:noFill/>
+        </p:spPr>
+        <p:txBody>
+          <a:bodyPr wrap="square">
+            <a:spAutoFit/>
+          </a:bodyPr>
+          <a:lstStyle/>
+          <a:p>
+            <a:r>
+              <a:rPr sz="1700" b="0">
+                <a:solidFill>
+                  <a:srgbClr val="FFFFFF"/>
+                </a:solidFill>
+              </a:rPr>
+              <a:t>Classify + critique: label each capability by type; flag raw-executor or hidden-write anti-patterns.</a:t>
             </a:r>
           </a:p>
         </p:txBody>
@@ -4434,7 +4599,7 @@
         <p:spPr>
           <a:xfrm>
             <a:off x="914400" y="3200400"/>
-            <a:ext cx="10332720" cy="1097280"/>
+            <a:ext cx="10332720" cy="730000"/>
           </a:xfrm>
           <a:prstGeom prst="rect">
             <a:avLst/>
@@ -4454,7 +4619,7 @@
                   <a:srgbClr val="A1A1AA"/>
                 </a:solidFill>
               </a:rPr>
-              <a:t>Deploy a gateway with RBAC, rate limits, and JSONL auditing</a:t>
+              <a:t>You can now map any MCP server's tools, resources, and prompts</a:t>
             </a:r>
           </a:p>
         </p:txBody>
@@ -4489,6 +4654,72 @@
                 </a:solidFill>
               </a:rPr>
               <a:t>academy.kspl.tech | Koenig AI Academy</a:t>
+            </a:r>
+          </a:p>
+        </p:txBody>
+      </p:sp>
+      <p:sp>
+        <p:nvSpPr>
+          <p:cNvPr id="5" name="TextBox 4"/>
+          <p:cNvSpPr txBox="1"/>
+          <p:nvPr/>
+        </p:nvSpPr>
+        <p:spPr>
+          <a:xfrm>
+            <a:off x="731520" y="4050000"/>
+            <a:ext cx="10698480" cy="960120"/>
+          </a:xfrm>
+          <a:prstGeom prst="rect">
+            <a:avLst/>
+          </a:prstGeom>
+          <a:noFill/>
+        </p:spPr>
+        <p:txBody>
+          <a:bodyPr wrap="square">
+            <a:spAutoFit/>
+          </a:bodyPr>
+          <a:lstStyle/>
+          <a:p>
+            <a:r>
+              <a:rPr sz="2000" b="0">
+                <a:solidFill>
+                  <a:srgbClr val="A1A1AA"/>
+                </a:solidFill>
+              </a:rPr>
+              <a:t>You know why raw-executor anti-patterns break connector design</a:t>
+            </a:r>
+          </a:p>
+        </p:txBody>
+      </p:sp>
+      <p:sp>
+        <p:nvSpPr>
+          <p:cNvPr id="6" name="TextBox 5"/>
+          <p:cNvSpPr txBox="1"/>
+          <p:nvPr/>
+        </p:nvSpPr>
+        <p:spPr>
+          <a:xfrm>
+            <a:off x="731520" y="4900000"/>
+            <a:ext cx="10698480" cy="960120"/>
+          </a:xfrm>
+          <a:prstGeom prst="rect">
+            <a:avLst/>
+          </a:prstGeom>
+          <a:noFill/>
+        </p:spPr>
+        <p:txBody>
+          <a:bodyPr wrap="square">
+            <a:spAutoFit/>
+          </a:bodyPr>
+          <a:lstStyle/>
+          <a:p>
+            <a:r>
+              <a:rPr sz="2000" b="0">
+                <a:solidFill>
+                  <a:srgbClr val="A1A1AA"/>
+                </a:solidFill>
+              </a:rPr>
+              <a:t>Try it: deploy a gateway with RBAC, rate limits, and JSONL auditing → Chapter 3</a:t>
             </a:r>
           </a:p>
         </p:txBody>

</xml_diff>